<commit_message>
refactor: Xóa phần AI Recommendation, giảm xuống 21 slides
- Xóa tất cả nội dung liên quan AI/Recommendation (PhoBERT, ALS)
- Xóa Recommend Service khỏi bảng services
- Xóa slide Recommendation System
- Xóa diagrams/seq-recommend.png
- Giảm 23 → 21 slides
- Regenerate DOCX và PPTX
</commit_message>
<xml_diff>
--- a/SmartVN-Slides.pptx
+++ b/SmartVN-Slides.pptx
@@ -26,8 +26,6 @@
     <p:sldId id="274" r:id="rId25"/>
     <p:sldId id="275" r:id="rId26"/>
     <p:sldId id="276" r:id="rId27"/>
-    <p:sldId id="277" r:id="rId28"/>
-    <p:sldId id="278" r:id="rId29"/>
   </p:sldIdLst>
   <p:sldSz cx="12191695" cy="6858000" type="screen4x3"/>
   <p:notesSz cx="6858000" cy="9144000"/>
@@ -3213,7 +3211,7 @@
               </a:defRPr>
             </a:pPr>
             <a:r>
-              <a:t>Kiến trúc Microservices • Spring Boot • Mobile Android • AI Recommendation</a:t>
+              <a:t>Kiến trúc Microservices • Spring Boot • Mobile Android</a:t>
             </a:r>
           </a:p>
         </p:txBody>
@@ -3973,21 +3971,6 @@
               </a:defRPr>
             </a:pPr>
             <a:r>
-              <a:t>• Nhận gợi ý AI (PhoBERT + ALS)</a:t>
-            </a:r>
-          </a:p>
-          <a:p>
-            <a:pPr>
-              <a:spcBef>
-                <a:spcPts val="500"/>
-              </a:spcBef>
-              <a:defRPr sz="1500">
-                <a:solidFill>
-                  <a:srgbClr val="2C3E50"/>
-                </a:solidFill>
-              </a:defRPr>
-            </a:pPr>
-            <a:r>
               <a:t>• Giỏ hàng → Đặt hàng → Thanh toán VNPay</a:t>
             </a:r>
           </a:p>
@@ -4796,21 +4779,6 @@
             </a:pPr>
             <a:r>
               <a:t>• Nút Add to Cart + Buy Now</a:t>
-            </a:r>
-          </a:p>
-          <a:p>
-            <a:pPr>
-              <a:spcBef>
-                <a:spcPts val="500"/>
-              </a:spcBef>
-              <a:defRPr sz="1500">
-                <a:solidFill>
-                  <a:srgbClr val="2C3E50"/>
-                </a:solidFill>
-              </a:defRPr>
-            </a:pPr>
-            <a:r>
-              <a:t>• Gợi ý sản phẩm tương tự (AI)</a:t>
             </a:r>
           </a:p>
         </p:txBody>
@@ -5669,7 +5637,7 @@
               </a:defRPr>
             </a:pPr>
             <a:r>
-              <a:t>04  AI RECOMMENDATION SYSTEM</a:t>
+              <a:t>05  KẾT LUẬN</a:t>
             </a:r>
           </a:p>
         </p:txBody>
@@ -5683,742 +5651,6 @@
 </file>
 
 <file path=ppt/slides/slide18.xml><?xml version="1.0" encoding="utf-8"?>
-<p:sld xmlns:a="http://schemas.openxmlformats.org/drawingml/2006/main" xmlns:p="http://schemas.openxmlformats.org/presentationml/2006/main" xmlns:r="http://schemas.openxmlformats.org/officeDocument/2006/relationships">
-  <p:cSld>
-    <p:spTree>
-      <p:nvGrpSpPr>
-        <p:cNvPr id="1" name=""/>
-        <p:cNvGrpSpPr/>
-        <p:nvPr/>
-      </p:nvGrpSpPr>
-      <p:grpSpPr/>
-      <p:sp>
-        <p:nvSpPr>
-          <p:cNvPr id="2" name="Rectangle 1"/>
-          <p:cNvSpPr/>
-          <p:nvPr/>
-        </p:nvSpPr>
-        <p:spPr>
-          <a:xfrm>
-            <a:off x="0" y="0"/>
-            <a:ext cx="12191695" cy="54864"/>
-          </a:xfrm>
-          <a:prstGeom prst="rect">
-            <a:avLst/>
-          </a:prstGeom>
-          <a:solidFill>
-            <a:srgbClr val="2E86DE"/>
-          </a:solidFill>
-          <a:ln>
-            <a:noFill/>
-          </a:ln>
-        </p:spPr>
-        <p:style>
-          <a:lnRef idx="1">
-            <a:schemeClr val="accent1"/>
-          </a:lnRef>
-          <a:fillRef idx="3">
-            <a:schemeClr val="accent1"/>
-          </a:fillRef>
-          <a:effectRef idx="2">
-            <a:schemeClr val="accent1"/>
-          </a:effectRef>
-          <a:fontRef idx="minor">
-            <a:schemeClr val="lt1"/>
-          </a:fontRef>
-        </p:style>
-        <p:txBody>
-          <a:bodyPr rtlCol="0" anchor="ctr"/>
-          <a:lstStyle/>
-          <a:p>
-            <a:pPr algn="ctr"/>
-          </a:p>
-        </p:txBody>
-      </p:sp>
-      <p:sp>
-        <p:nvSpPr>
-          <p:cNvPr id="3" name="Rectangle 2"/>
-          <p:cNvSpPr/>
-          <p:nvPr/>
-        </p:nvSpPr>
-        <p:spPr>
-          <a:xfrm>
-            <a:off x="0" y="6492240"/>
-            <a:ext cx="12191695" cy="365760"/>
-          </a:xfrm>
-          <a:prstGeom prst="rect">
-            <a:avLst/>
-          </a:prstGeom>
-          <a:solidFill>
-            <a:srgbClr val="1B2A4A"/>
-          </a:solidFill>
-          <a:ln>
-            <a:noFill/>
-          </a:ln>
-        </p:spPr>
-        <p:style>
-          <a:lnRef idx="1">
-            <a:schemeClr val="accent1"/>
-          </a:lnRef>
-          <a:fillRef idx="3">
-            <a:schemeClr val="accent1"/>
-          </a:fillRef>
-          <a:effectRef idx="2">
-            <a:schemeClr val="accent1"/>
-          </a:effectRef>
-          <a:fontRef idx="minor">
-            <a:schemeClr val="lt1"/>
-          </a:fontRef>
-        </p:style>
-        <p:txBody>
-          <a:bodyPr rtlCol="0" anchor="ctr"/>
-          <a:lstStyle/>
-          <a:p>
-            <a:pPr algn="ctr">
-              <a:defRPr sz="1000">
-                <a:solidFill>
-                  <a:srgbClr val="FFFFFF"/>
-                </a:solidFill>
-              </a:defRPr>
-            </a:pPr>
-            <a:r>
-              <a:t>SmartVN — Hệ thống TMĐT Microservices</a:t>
-            </a:r>
-          </a:p>
-        </p:txBody>
-      </p:sp>
-      <p:sp>
-        <p:nvSpPr>
-          <p:cNvPr id="4" name="TextBox 3"/>
-          <p:cNvSpPr txBox="1"/>
-          <p:nvPr/>
-        </p:nvSpPr>
-        <p:spPr>
-          <a:xfrm>
-            <a:off x="457200" y="137160"/>
-            <a:ext cx="10972800" cy="731520"/>
-          </a:xfrm>
-          <a:prstGeom prst="rect">
-            <a:avLst/>
-          </a:prstGeom>
-          <a:noFill/>
-        </p:spPr>
-        <p:txBody>
-          <a:bodyPr wrap="none">
-            <a:spAutoFit/>
-          </a:bodyPr>
-          <a:lstStyle/>
-          <a:p>
-            <a:pPr>
-              <a:defRPr sz="2600" b="1">
-                <a:solidFill>
-                  <a:srgbClr val="1B2A4A"/>
-                </a:solidFill>
-              </a:defRPr>
-            </a:pPr>
-            <a:r>
-              <a:t>HYBRID RECOMMENDATION — PhoBERT + ALS</a:t>
-            </a:r>
-          </a:p>
-        </p:txBody>
-      </p:sp>
-      <p:sp>
-        <p:nvSpPr>
-          <p:cNvPr id="5" name="TextBox 4"/>
-          <p:cNvSpPr txBox="1"/>
-          <p:nvPr/>
-        </p:nvSpPr>
-        <p:spPr>
-          <a:xfrm>
-            <a:off x="457200" y="1005840"/>
-            <a:ext cx="5669280" cy="5029200"/>
-          </a:xfrm>
-          <a:prstGeom prst="rect">
-            <a:avLst/>
-          </a:prstGeom>
-          <a:noFill/>
-        </p:spPr>
-        <p:txBody>
-          <a:bodyPr wrap="square">
-            <a:spAutoFit/>
-          </a:bodyPr>
-          <a:lstStyle/>
-          <a:p>
-            <a:pPr>
-              <a:spcBef>
-                <a:spcPts val="1400"/>
-              </a:spcBef>
-              <a:defRPr sz="1700" b="1">
-                <a:solidFill>
-                  <a:srgbClr val="2E86DE"/>
-                </a:solidFill>
-              </a:defRPr>
-            </a:pPr>
-            <a:r>
-              <a:t>Content-Based: PhoBERT</a:t>
-            </a:r>
-          </a:p>
-          <a:p>
-            <a:pPr>
-              <a:spcBef>
-                <a:spcPts val="500"/>
-              </a:spcBef>
-              <a:defRPr sz="1500">
-                <a:solidFill>
-                  <a:srgbClr val="2C3E50"/>
-                </a:solidFill>
-              </a:defRPr>
-            </a:pPr>
-            <a:r>
-              <a:t>• Pre-trained Vietnamese language model (VinAI)</a:t>
-            </a:r>
-          </a:p>
-          <a:p>
-            <a:pPr>
-              <a:spcBef>
-                <a:spcPts val="500"/>
-              </a:spcBef>
-              <a:defRPr sz="1500">
-                <a:solidFill>
-                  <a:srgbClr val="2C3E50"/>
-                </a:solidFill>
-              </a:defRPr>
-            </a:pPr>
-            <a:r>
-              <a:t>• Phân tích mô tả sản phẩm → text embeddings</a:t>
-            </a:r>
-          </a:p>
-          <a:p>
-            <a:pPr>
-              <a:spcBef>
-                <a:spcPts val="500"/>
-              </a:spcBef>
-              <a:defRPr sz="1500">
-                <a:solidFill>
-                  <a:srgbClr val="2C3E50"/>
-                </a:solidFill>
-              </a:defRPr>
-            </a:pPr>
-            <a:r>
-              <a:t>• Tính similarity giữa sản phẩm</a:t>
-            </a:r>
-          </a:p>
-          <a:p>
-            <a:pPr>
-              <a:spcBef>
-                <a:spcPts val="500"/>
-              </a:spcBef>
-              <a:defRPr sz="1500">
-                <a:solidFill>
-                  <a:srgbClr val="2C3E50"/>
-                </a:solidFill>
-              </a:defRPr>
-            </a:pPr>
-          </a:p>
-          <a:p>
-            <a:pPr>
-              <a:spcBef>
-                <a:spcPts val="1400"/>
-              </a:spcBef>
-              <a:defRPr sz="1700" b="1">
-                <a:solidFill>
-                  <a:srgbClr val="2E86DE"/>
-                </a:solidFill>
-              </a:defRPr>
-            </a:pPr>
-            <a:r>
-              <a:t>Collaborative: ALS</a:t>
-            </a:r>
-          </a:p>
-          <a:p>
-            <a:pPr>
-              <a:spcBef>
-                <a:spcPts val="500"/>
-              </a:spcBef>
-              <a:defRPr sz="1500">
-                <a:solidFill>
-                  <a:srgbClr val="2C3E50"/>
-                </a:solidFill>
-              </a:defRPr>
-            </a:pPr>
-            <a:r>
-              <a:t>• Alternating Least Squares</a:t>
-            </a:r>
-          </a:p>
-          <a:p>
-            <a:pPr>
-              <a:spcBef>
-                <a:spcPts val="500"/>
-              </a:spcBef>
-              <a:defRPr sz="1500">
-                <a:solidFill>
-                  <a:srgbClr val="2C3E50"/>
-                </a:solidFill>
-              </a:defRPr>
-            </a:pPr>
-            <a:r>
-              <a:t>• Học từ lịch sử mua hàng user-item matrix</a:t>
-            </a:r>
-          </a:p>
-          <a:p>
-            <a:pPr>
-              <a:spcBef>
-                <a:spcPts val="500"/>
-              </a:spcBef>
-              <a:defRPr sz="1500">
-                <a:solidFill>
-                  <a:srgbClr val="2C3E50"/>
-                </a:solidFill>
-              </a:defRPr>
-            </a:pPr>
-            <a:r>
-              <a:t>• Dự đoán user sẽ thích sản phẩm nào</a:t>
-            </a:r>
-          </a:p>
-          <a:p>
-            <a:pPr>
-              <a:spcBef>
-                <a:spcPts val="500"/>
-              </a:spcBef>
-              <a:defRPr sz="1500">
-                <a:solidFill>
-                  <a:srgbClr val="2C3E50"/>
-                </a:solidFill>
-              </a:defRPr>
-            </a:pPr>
-          </a:p>
-          <a:p>
-            <a:pPr>
-              <a:spcBef>
-                <a:spcPts val="1400"/>
-              </a:spcBef>
-              <a:defRPr sz="1700" b="1">
-                <a:solidFill>
-                  <a:srgbClr val="2E86DE"/>
-                </a:solidFill>
-              </a:defRPr>
-            </a:pPr>
-            <a:r>
-              <a:t>Hybrid Merge</a:t>
-            </a:r>
-          </a:p>
-          <a:p>
-            <a:pPr>
-              <a:spcBef>
-                <a:spcPts val="500"/>
-              </a:spcBef>
-              <a:defRPr sz="1500">
-                <a:solidFill>
-                  <a:srgbClr val="2C3E50"/>
-                </a:solidFill>
-              </a:defRPr>
-            </a:pPr>
-            <a:r>
-              <a:t>• Kết hợp điểm từ cả 2 model</a:t>
-            </a:r>
-          </a:p>
-          <a:p>
-            <a:pPr>
-              <a:spcBef>
-                <a:spcPts val="500"/>
-              </a:spcBef>
-              <a:defRPr sz="1500">
-                <a:solidFill>
-                  <a:srgbClr val="2C3E50"/>
-                </a:solidFill>
-              </a:defRPr>
-            </a:pPr>
-            <a:r>
-              <a:t>• Cold start: user mới → Content-Based</a:t>
-            </a:r>
-          </a:p>
-          <a:p>
-            <a:pPr>
-              <a:spcBef>
-                <a:spcPts val="500"/>
-              </a:spcBef>
-              <a:defRPr sz="1500">
-                <a:solidFill>
-                  <a:srgbClr val="2C3E50"/>
-                </a:solidFill>
-              </a:defRPr>
-            </a:pPr>
-            <a:r>
-              <a:t>• Warm user → Collaborative ưu tiên hơn</a:t>
-            </a:r>
-          </a:p>
-        </p:txBody>
-      </p:sp>
-      <p:pic>
-        <p:nvPicPr>
-          <p:cNvPr id="6" name="Picture 5" descr="img-040.jpg"/>
-          <p:cNvPicPr>
-            <a:picLocks noChangeAspect="1"/>
-          </p:cNvPicPr>
-          <p:nvPr/>
-        </p:nvPicPr>
-        <p:blipFill>
-          <a:blip r:embed="rId2"/>
-          <a:stretch>
-            <a:fillRect/>
-          </a:stretch>
-        </p:blipFill>
-        <p:spPr>
-          <a:xfrm>
-            <a:off x="6400800" y="1097280"/>
-            <a:ext cx="5303520" cy="5029200"/>
-          </a:xfrm>
-          <a:prstGeom prst="rect">
-            <a:avLst/>
-          </a:prstGeom>
-        </p:spPr>
-      </p:pic>
-    </p:spTree>
-  </p:cSld>
-  <p:clrMapOvr>
-    <a:masterClrMapping/>
-  </p:clrMapOvr>
-</p:sld>
-</file>
-
-<file path=ppt/slides/slide19.xml><?xml version="1.0" encoding="utf-8"?>
-<p:sld xmlns:a="http://schemas.openxmlformats.org/drawingml/2006/main" xmlns:p="http://schemas.openxmlformats.org/presentationml/2006/main" xmlns:r="http://schemas.openxmlformats.org/officeDocument/2006/relationships">
-  <p:cSld>
-    <p:bg>
-      <p:bgPr>
-        <a:solidFill>
-          <a:srgbClr val="2E86DE"/>
-        </a:solidFill>
-        <a:effectLst/>
-      </p:bgPr>
-    </p:bg>
-    <p:spTree>
-      <p:nvGrpSpPr>
-        <p:cNvPr id="1" name=""/>
-        <p:cNvGrpSpPr/>
-        <p:nvPr/>
-      </p:nvGrpSpPr>
-      <p:grpSpPr/>
-      <p:sp>
-        <p:nvSpPr>
-          <p:cNvPr id="2" name="TextBox 1"/>
-          <p:cNvSpPr txBox="1"/>
-          <p:nvPr/>
-        </p:nvSpPr>
-        <p:spPr>
-          <a:xfrm>
-            <a:off x="914400" y="2743200"/>
-            <a:ext cx="9144000" cy="1371600"/>
-          </a:xfrm>
-          <a:prstGeom prst="rect">
-            <a:avLst/>
-          </a:prstGeom>
-          <a:noFill/>
-        </p:spPr>
-        <p:txBody>
-          <a:bodyPr wrap="none">
-            <a:spAutoFit/>
-          </a:bodyPr>
-          <a:lstStyle/>
-          <a:p>
-            <a:pPr>
-              <a:defRPr sz="3600" b="1">
-                <a:solidFill>
-                  <a:srgbClr val="FFFFFF"/>
-                </a:solidFill>
-              </a:defRPr>
-            </a:pPr>
-            <a:r>
-              <a:t>05  KIỂM THỬ &amp; HIỆU NĂNG</a:t>
-            </a:r>
-          </a:p>
-        </p:txBody>
-      </p:sp>
-    </p:spTree>
-  </p:cSld>
-  <p:clrMapOvr>
-    <a:masterClrMapping/>
-  </p:clrMapOvr>
-</p:sld>
-</file>
-
-<file path=ppt/slides/slide2.xml><?xml version="1.0" encoding="utf-8"?>
-<p:sld xmlns:a="http://schemas.openxmlformats.org/drawingml/2006/main" xmlns:p="http://schemas.openxmlformats.org/presentationml/2006/main" xmlns:r="http://schemas.openxmlformats.org/officeDocument/2006/relationships">
-  <p:cSld>
-    <p:spTree>
-      <p:nvGrpSpPr>
-        <p:cNvPr id="1" name=""/>
-        <p:cNvGrpSpPr/>
-        <p:nvPr/>
-      </p:nvGrpSpPr>
-      <p:grpSpPr/>
-      <p:sp>
-        <p:nvSpPr>
-          <p:cNvPr id="2" name="Rectangle 1"/>
-          <p:cNvSpPr/>
-          <p:nvPr/>
-        </p:nvSpPr>
-        <p:spPr>
-          <a:xfrm>
-            <a:off x="0" y="0"/>
-            <a:ext cx="12191695" cy="54864"/>
-          </a:xfrm>
-          <a:prstGeom prst="rect">
-            <a:avLst/>
-          </a:prstGeom>
-          <a:solidFill>
-            <a:srgbClr val="2E86DE"/>
-          </a:solidFill>
-          <a:ln>
-            <a:noFill/>
-          </a:ln>
-        </p:spPr>
-        <p:style>
-          <a:lnRef idx="1">
-            <a:schemeClr val="accent1"/>
-          </a:lnRef>
-          <a:fillRef idx="3">
-            <a:schemeClr val="accent1"/>
-          </a:fillRef>
-          <a:effectRef idx="2">
-            <a:schemeClr val="accent1"/>
-          </a:effectRef>
-          <a:fontRef idx="minor">
-            <a:schemeClr val="lt1"/>
-          </a:fontRef>
-        </p:style>
-        <p:txBody>
-          <a:bodyPr rtlCol="0" anchor="ctr"/>
-          <a:lstStyle/>
-          <a:p>
-            <a:pPr algn="ctr"/>
-          </a:p>
-        </p:txBody>
-      </p:sp>
-      <p:sp>
-        <p:nvSpPr>
-          <p:cNvPr id="3" name="Rectangle 2"/>
-          <p:cNvSpPr/>
-          <p:nvPr/>
-        </p:nvSpPr>
-        <p:spPr>
-          <a:xfrm>
-            <a:off x="0" y="6492240"/>
-            <a:ext cx="12191695" cy="365760"/>
-          </a:xfrm>
-          <a:prstGeom prst="rect">
-            <a:avLst/>
-          </a:prstGeom>
-          <a:solidFill>
-            <a:srgbClr val="1B2A4A"/>
-          </a:solidFill>
-          <a:ln>
-            <a:noFill/>
-          </a:ln>
-        </p:spPr>
-        <p:style>
-          <a:lnRef idx="1">
-            <a:schemeClr val="accent1"/>
-          </a:lnRef>
-          <a:fillRef idx="3">
-            <a:schemeClr val="accent1"/>
-          </a:fillRef>
-          <a:effectRef idx="2">
-            <a:schemeClr val="accent1"/>
-          </a:effectRef>
-          <a:fontRef idx="minor">
-            <a:schemeClr val="lt1"/>
-          </a:fontRef>
-        </p:style>
-        <p:txBody>
-          <a:bodyPr rtlCol="0" anchor="ctr"/>
-          <a:lstStyle/>
-          <a:p>
-            <a:pPr algn="ctr">
-              <a:defRPr sz="1000">
-                <a:solidFill>
-                  <a:srgbClr val="FFFFFF"/>
-                </a:solidFill>
-              </a:defRPr>
-            </a:pPr>
-            <a:r>
-              <a:t>SmartVN — Hệ thống TMĐT Microservices</a:t>
-            </a:r>
-          </a:p>
-        </p:txBody>
-      </p:sp>
-      <p:sp>
-        <p:nvSpPr>
-          <p:cNvPr id="4" name="TextBox 3"/>
-          <p:cNvSpPr txBox="1"/>
-          <p:nvPr/>
-        </p:nvSpPr>
-        <p:spPr>
-          <a:xfrm>
-            <a:off x="457200" y="137160"/>
-            <a:ext cx="10972800" cy="731520"/>
-          </a:xfrm>
-          <a:prstGeom prst="rect">
-            <a:avLst/>
-          </a:prstGeom>
-          <a:noFill/>
-        </p:spPr>
-        <p:txBody>
-          <a:bodyPr wrap="none">
-            <a:spAutoFit/>
-          </a:bodyPr>
-          <a:lstStyle/>
-          <a:p>
-            <a:pPr>
-              <a:defRPr sz="2600" b="1">
-                <a:solidFill>
-                  <a:srgbClr val="1B2A4A"/>
-                </a:solidFill>
-              </a:defRPr>
-            </a:pPr>
-            <a:r>
-              <a:t>NỘI DUNG</a:t>
-            </a:r>
-          </a:p>
-        </p:txBody>
-      </p:sp>
-      <p:sp>
-        <p:nvSpPr>
-          <p:cNvPr id="5" name="TextBox 4"/>
-          <p:cNvSpPr txBox="1"/>
-          <p:nvPr/>
-        </p:nvSpPr>
-        <p:spPr>
-          <a:xfrm>
-            <a:off x="457200" y="1005840"/>
-            <a:ext cx="5669280" cy="5029200"/>
-          </a:xfrm>
-          <a:prstGeom prst="rect">
-            <a:avLst/>
-          </a:prstGeom>
-          <a:noFill/>
-        </p:spPr>
-        <p:txBody>
-          <a:bodyPr wrap="square">
-            <a:spAutoFit/>
-          </a:bodyPr>
-          <a:lstStyle/>
-          <a:p>
-            <a:pPr>
-              <a:spcBef>
-                <a:spcPts val="1400"/>
-              </a:spcBef>
-              <a:defRPr sz="1700" b="1">
-                <a:solidFill>
-                  <a:srgbClr val="2E86DE"/>
-                </a:solidFill>
-              </a:defRPr>
-            </a:pPr>
-            <a:r>
-              <a:t>1. Tổng quan đề tài</a:t>
-            </a:r>
-          </a:p>
-          <a:p>
-            <a:pPr>
-              <a:spcBef>
-                <a:spcPts val="1400"/>
-              </a:spcBef>
-              <a:defRPr sz="1700" b="1">
-                <a:solidFill>
-                  <a:srgbClr val="2E86DE"/>
-                </a:solidFill>
-              </a:defRPr>
-            </a:pPr>
-            <a:r>
-              <a:t>2. Kiến trúc Microservices</a:t>
-            </a:r>
-          </a:p>
-          <a:p>
-            <a:pPr>
-              <a:spcBef>
-                <a:spcPts val="1400"/>
-              </a:spcBef>
-              <a:defRPr sz="1700" b="1">
-                <a:solidFill>
-                  <a:srgbClr val="2E86DE"/>
-                </a:solidFill>
-              </a:defRPr>
-            </a:pPr>
-            <a:r>
-              <a:t>3. Ứng dụng Mobile Android (MVVM)</a:t>
-            </a:r>
-          </a:p>
-          <a:p>
-            <a:pPr>
-              <a:spcBef>
-                <a:spcPts val="1400"/>
-              </a:spcBef>
-              <a:defRPr sz="1700" b="1">
-                <a:solidFill>
-                  <a:srgbClr val="2E86DE"/>
-                </a:solidFill>
-              </a:defRPr>
-            </a:pPr>
-            <a:r>
-              <a:t>4. Giao diện Mobile</a:t>
-            </a:r>
-          </a:p>
-          <a:p>
-            <a:pPr>
-              <a:spcBef>
-                <a:spcPts val="1400"/>
-              </a:spcBef>
-              <a:defRPr sz="1700" b="1">
-                <a:solidFill>
-                  <a:srgbClr val="2E86DE"/>
-                </a:solidFill>
-              </a:defRPr>
-            </a:pPr>
-            <a:r>
-              <a:t>5. Recommendation System</a:t>
-            </a:r>
-          </a:p>
-          <a:p>
-            <a:pPr>
-              <a:spcBef>
-                <a:spcPts val="1400"/>
-              </a:spcBef>
-              <a:defRPr sz="1700" b="1">
-                <a:solidFill>
-                  <a:srgbClr val="2E86DE"/>
-                </a:solidFill>
-              </a:defRPr>
-            </a:pPr>
-            <a:r>
-              <a:t>6. Kiểm thử &amp; Hiệu năng</a:t>
-            </a:r>
-          </a:p>
-          <a:p>
-            <a:pPr>
-              <a:spcBef>
-                <a:spcPts val="1400"/>
-              </a:spcBef>
-              <a:defRPr sz="1700" b="1">
-                <a:solidFill>
-                  <a:srgbClr val="2E86DE"/>
-                </a:solidFill>
-              </a:defRPr>
-            </a:pPr>
-            <a:r>
-              <a:t>7. Kết luận</a:t>
-            </a:r>
-          </a:p>
-        </p:txBody>
-      </p:sp>
-    </p:spTree>
-  </p:cSld>
-  <p:clrMapOvr>
-    <a:masterClrMapping/>
-  </p:clrMapOvr>
-</p:sld>
-</file>
-
-<file path=ppt/slides/slide20.xml><?xml version="1.0" encoding="utf-8"?>
 <p:sld xmlns:a="http://schemas.openxmlformats.org/drawingml/2006/main" xmlns:p="http://schemas.openxmlformats.org/presentationml/2006/main" xmlns:r="http://schemas.openxmlformats.org/officeDocument/2006/relationships">
   <p:cSld>
     <p:spTree>
@@ -7115,7 +6347,7 @@
 </p:sld>
 </file>
 
-<file path=ppt/slides/slide21.xml><?xml version="1.0" encoding="utf-8"?>
+<file path=ppt/slides/slide19.xml><?xml version="1.0" encoding="utf-8"?>
 <p:sld xmlns:a="http://schemas.openxmlformats.org/drawingml/2006/main" xmlns:p="http://schemas.openxmlformats.org/presentationml/2006/main" xmlns:r="http://schemas.openxmlformats.org/officeDocument/2006/relationships">
   <p:cSld>
     <p:bg>
@@ -7163,7 +6395,7 @@
               </a:defRPr>
             </a:pPr>
             <a:r>
-              <a:t>06  KẾT LUẬN</a:t>
+              <a:t>06  CẢM ƠN</a:t>
             </a:r>
           </a:p>
         </p:txBody>
@@ -7176,7 +6408,7 @@
 </p:sld>
 </file>
 
-<file path=ppt/slides/slide22.xml><?xml version="1.0" encoding="utf-8"?>
+<file path=ppt/slides/slide2.xml><?xml version="1.0" encoding="utf-8"?>
 <p:sld xmlns:a="http://schemas.openxmlformats.org/drawingml/2006/main" xmlns:p="http://schemas.openxmlformats.org/presentationml/2006/main" xmlns:r="http://schemas.openxmlformats.org/officeDocument/2006/relationships">
   <p:cSld>
     <p:spTree>
@@ -7311,7 +6543,7 @@
               </a:defRPr>
             </a:pPr>
             <a:r>
-              <a:t>KẾT QUẢ &amp; HƯỚNG PHÁT TRIỂN</a:t>
+              <a:t>NỘI DUNG</a:t>
             </a:r>
           </a:p>
         </p:txBody>
@@ -7349,110 +6581,8 @@
               </a:defRPr>
             </a:pPr>
             <a:r>
-              <a:t>Kết quả đạt được</a:t>
-            </a:r>
-          </a:p>
-          <a:p>
-            <a:pPr>
-              <a:spcBef>
-                <a:spcPts val="500"/>
-              </a:spcBef>
-              <a:defRPr sz="1500">
-                <a:solidFill>
-                  <a:srgbClr val="2C3E50"/>
-                </a:solidFill>
-              </a:defRPr>
-            </a:pPr>
-            <a:r>
-              <a:t>• Hệ thống TMĐT SmartVN hoàn chỉnh (7 microservices)</a:t>
-            </a:r>
-          </a:p>
-          <a:p>
-            <a:pPr>
-              <a:spcBef>
-                <a:spcPts val="500"/>
-              </a:spcBef>
-              <a:defRPr sz="1500">
-                <a:solidFill>
-                  <a:srgbClr val="2C3E50"/>
-                </a:solidFill>
-              </a:defRPr>
-            </a:pPr>
-            <a:r>
-              <a:t>• Ứng dụng Mobile Android native (MVVM) đầy đủ tính năng</a:t>
-            </a:r>
-          </a:p>
-          <a:p>
-            <a:pPr>
-              <a:spcBef>
-                <a:spcPts val="500"/>
-              </a:spcBef>
-              <a:defRPr sz="1500">
-                <a:solidFill>
-                  <a:srgbClr val="2C3E50"/>
-                </a:solidFill>
-              </a:defRPr>
-            </a:pPr>
-            <a:r>
-              <a:t>• AI Recommendation (PhoBERT + ALS Hybrid)</a:t>
-            </a:r>
-          </a:p>
-          <a:p>
-            <a:pPr>
-              <a:spcBef>
-                <a:spcPts val="500"/>
-              </a:spcBef>
-              <a:defRPr sz="1500">
-                <a:solidFill>
-                  <a:srgbClr val="2C3E50"/>
-                </a:solidFill>
-              </a:defRPr>
-            </a:pPr>
-            <a:r>
-              <a:t>• Hiệu năng: Redis cache giảm latency 5.5x</a:t>
-            </a:r>
-          </a:p>
-          <a:p>
-            <a:pPr>
-              <a:spcBef>
-                <a:spcPts val="500"/>
-              </a:spcBef>
-              <a:defRPr sz="1500">
-                <a:solidFill>
-                  <a:srgbClr val="2C3E50"/>
-                </a:solidFill>
-              </a:defRPr>
-            </a:pPr>
-            <a:r>
-              <a:t>• Bảo mật: JWT + OAuth2 + Circuit Breaker</a:t>
-            </a:r>
-          </a:p>
-          <a:p>
-            <a:pPr>
-              <a:spcBef>
-                <a:spcPts val="500"/>
-              </a:spcBef>
-              <a:defRPr sz="1500">
-                <a:solidFill>
-                  <a:srgbClr val="2C3E50"/>
-                </a:solidFill>
-              </a:defRPr>
-            </a:pPr>
-            <a:r>
-              <a:t>• Docker Compose deployment</a:t>
-            </a:r>
-          </a:p>
-          <a:p>
-            <a:pPr>
-              <a:spcBef>
-                <a:spcPts val="500"/>
-              </a:spcBef>
-              <a:defRPr sz="1500">
-                <a:solidFill>
-                  <a:srgbClr val="2C3E50"/>
-                </a:solidFill>
-              </a:defRPr>
-            </a:pPr>
+              <a:t>1. Tổng quan đề tài</a:t>
+            </a:r>
           </a:p>
           <a:p>
             <a:pPr>
@@ -7466,82 +6596,67 @@
               </a:defRPr>
             </a:pPr>
             <a:r>
-              <a:t>Hướng phát triển</a:t>
-            </a:r>
-          </a:p>
-          <a:p>
-            <a:pPr>
-              <a:spcBef>
-                <a:spcPts val="500"/>
-              </a:spcBef>
-              <a:defRPr sz="1500">
-                <a:solidFill>
-                  <a:srgbClr val="2C3E50"/>
-                </a:solidFill>
-              </a:defRPr>
-            </a:pPr>
-            <a:r>
-              <a:t>• CI/CD pipeline (GitHub Actions)</a:t>
-            </a:r>
-          </a:p>
-          <a:p>
-            <a:pPr>
-              <a:spcBef>
-                <a:spcPts val="500"/>
-              </a:spcBef>
-              <a:defRPr sz="1500">
-                <a:solidFill>
-                  <a:srgbClr val="2C3E50"/>
-                </a:solidFill>
-              </a:defRPr>
-            </a:pPr>
-            <a:r>
-              <a:t>• Monitoring (Prometheus + Grafana)</a:t>
-            </a:r>
-          </a:p>
-          <a:p>
-            <a:pPr>
-              <a:spcBef>
-                <a:spcPts val="500"/>
-              </a:spcBef>
-              <a:defRPr sz="1500">
-                <a:solidFill>
-                  <a:srgbClr val="2C3E50"/>
-                </a:solidFill>
-              </a:defRPr>
-            </a:pPr>
-            <a:r>
-              <a:t>• Push notification (Firebase FCM)</a:t>
-            </a:r>
-          </a:p>
-          <a:p>
-            <a:pPr>
-              <a:spcBef>
-                <a:spcPts val="500"/>
-              </a:spcBef>
-              <a:defRPr sz="1500">
-                <a:solidFill>
-                  <a:srgbClr val="2C3E50"/>
-                </a:solidFill>
-              </a:defRPr>
-            </a:pPr>
-            <a:r>
-              <a:t>• Elasticsearch full-text search</a:t>
-            </a:r>
-          </a:p>
-          <a:p>
-            <a:pPr>
-              <a:spcBef>
-                <a:spcPts val="500"/>
-              </a:spcBef>
-              <a:defRPr sz="1500">
-                <a:solidFill>
-                  <a:srgbClr val="2C3E50"/>
-                </a:solidFill>
-              </a:defRPr>
-            </a:pPr>
-            <a:r>
-              <a:t>• iOS app (Flutter cross-platform)</a:t>
+              <a:t>2. Kiến trúc Microservices</a:t>
+            </a:r>
+          </a:p>
+          <a:p>
+            <a:pPr>
+              <a:spcBef>
+                <a:spcPts val="1400"/>
+              </a:spcBef>
+              <a:defRPr sz="1700" b="1">
+                <a:solidFill>
+                  <a:srgbClr val="2E86DE"/>
+                </a:solidFill>
+              </a:defRPr>
+            </a:pPr>
+            <a:r>
+              <a:t>3. Ứng dụng Mobile Android (MVVM)</a:t>
+            </a:r>
+          </a:p>
+          <a:p>
+            <a:pPr>
+              <a:spcBef>
+                <a:spcPts val="1400"/>
+              </a:spcBef>
+              <a:defRPr sz="1700" b="1">
+                <a:solidFill>
+                  <a:srgbClr val="2E86DE"/>
+                </a:solidFill>
+              </a:defRPr>
+            </a:pPr>
+            <a:r>
+              <a:t>4. Giao diện Mobile</a:t>
+            </a:r>
+          </a:p>
+          <a:p>
+            <a:pPr>
+              <a:spcBef>
+                <a:spcPts val="1400"/>
+              </a:spcBef>
+              <a:defRPr sz="1700" b="1">
+                <a:solidFill>
+                  <a:srgbClr val="2E86DE"/>
+                </a:solidFill>
+              </a:defRPr>
+            </a:pPr>
+            <a:r>
+              <a:t>6. Kiểm thử &amp; Hiệu năng</a:t>
+            </a:r>
+          </a:p>
+          <a:p>
+            <a:pPr>
+              <a:spcBef>
+                <a:spcPts val="1400"/>
+              </a:spcBef>
+              <a:defRPr sz="1700" b="1">
+                <a:solidFill>
+                  <a:srgbClr val="2E86DE"/>
+                </a:solidFill>
+              </a:defRPr>
+            </a:pPr>
+            <a:r>
+              <a:t>7. Kết luận</a:t>
             </a:r>
           </a:p>
         </p:txBody>
@@ -7554,7 +6669,370 @@
 </p:sld>
 </file>
 
-<file path=ppt/slides/slide23.xml><?xml version="1.0" encoding="utf-8"?>
+<file path=ppt/slides/slide20.xml><?xml version="1.0" encoding="utf-8"?>
+<p:sld xmlns:a="http://schemas.openxmlformats.org/drawingml/2006/main" xmlns:p="http://schemas.openxmlformats.org/presentationml/2006/main" xmlns:r="http://schemas.openxmlformats.org/officeDocument/2006/relationships">
+  <p:cSld>
+    <p:spTree>
+      <p:nvGrpSpPr>
+        <p:cNvPr id="1" name=""/>
+        <p:cNvGrpSpPr/>
+        <p:nvPr/>
+      </p:nvGrpSpPr>
+      <p:grpSpPr/>
+      <p:sp>
+        <p:nvSpPr>
+          <p:cNvPr id="2" name="Rectangle 1"/>
+          <p:cNvSpPr/>
+          <p:nvPr/>
+        </p:nvSpPr>
+        <p:spPr>
+          <a:xfrm>
+            <a:off x="0" y="0"/>
+            <a:ext cx="12191695" cy="54864"/>
+          </a:xfrm>
+          <a:prstGeom prst="rect">
+            <a:avLst/>
+          </a:prstGeom>
+          <a:solidFill>
+            <a:srgbClr val="2E86DE"/>
+          </a:solidFill>
+          <a:ln>
+            <a:noFill/>
+          </a:ln>
+        </p:spPr>
+        <p:style>
+          <a:lnRef idx="1">
+            <a:schemeClr val="accent1"/>
+          </a:lnRef>
+          <a:fillRef idx="3">
+            <a:schemeClr val="accent1"/>
+          </a:fillRef>
+          <a:effectRef idx="2">
+            <a:schemeClr val="accent1"/>
+          </a:effectRef>
+          <a:fontRef idx="minor">
+            <a:schemeClr val="lt1"/>
+          </a:fontRef>
+        </p:style>
+        <p:txBody>
+          <a:bodyPr rtlCol="0" anchor="ctr"/>
+          <a:lstStyle/>
+          <a:p>
+            <a:pPr algn="ctr"/>
+          </a:p>
+        </p:txBody>
+      </p:sp>
+      <p:sp>
+        <p:nvSpPr>
+          <p:cNvPr id="3" name="Rectangle 2"/>
+          <p:cNvSpPr/>
+          <p:nvPr/>
+        </p:nvSpPr>
+        <p:spPr>
+          <a:xfrm>
+            <a:off x="0" y="6492240"/>
+            <a:ext cx="12191695" cy="365760"/>
+          </a:xfrm>
+          <a:prstGeom prst="rect">
+            <a:avLst/>
+          </a:prstGeom>
+          <a:solidFill>
+            <a:srgbClr val="1B2A4A"/>
+          </a:solidFill>
+          <a:ln>
+            <a:noFill/>
+          </a:ln>
+        </p:spPr>
+        <p:style>
+          <a:lnRef idx="1">
+            <a:schemeClr val="accent1"/>
+          </a:lnRef>
+          <a:fillRef idx="3">
+            <a:schemeClr val="accent1"/>
+          </a:fillRef>
+          <a:effectRef idx="2">
+            <a:schemeClr val="accent1"/>
+          </a:effectRef>
+          <a:fontRef idx="minor">
+            <a:schemeClr val="lt1"/>
+          </a:fontRef>
+        </p:style>
+        <p:txBody>
+          <a:bodyPr rtlCol="0" anchor="ctr"/>
+          <a:lstStyle/>
+          <a:p>
+            <a:pPr algn="ctr">
+              <a:defRPr sz="1000">
+                <a:solidFill>
+                  <a:srgbClr val="FFFFFF"/>
+                </a:solidFill>
+              </a:defRPr>
+            </a:pPr>
+            <a:r>
+              <a:t>SmartVN — Hệ thống TMĐT Microservices</a:t>
+            </a:r>
+          </a:p>
+        </p:txBody>
+      </p:sp>
+      <p:sp>
+        <p:nvSpPr>
+          <p:cNvPr id="4" name="TextBox 3"/>
+          <p:cNvSpPr txBox="1"/>
+          <p:nvPr/>
+        </p:nvSpPr>
+        <p:spPr>
+          <a:xfrm>
+            <a:off x="457200" y="137160"/>
+            <a:ext cx="10972800" cy="731520"/>
+          </a:xfrm>
+          <a:prstGeom prst="rect">
+            <a:avLst/>
+          </a:prstGeom>
+          <a:noFill/>
+        </p:spPr>
+        <p:txBody>
+          <a:bodyPr wrap="none">
+            <a:spAutoFit/>
+          </a:bodyPr>
+          <a:lstStyle/>
+          <a:p>
+            <a:pPr>
+              <a:defRPr sz="2600" b="1">
+                <a:solidFill>
+                  <a:srgbClr val="1B2A4A"/>
+                </a:solidFill>
+              </a:defRPr>
+            </a:pPr>
+            <a:r>
+              <a:t>KẾT QUẢ &amp; HƯỚNG PHÁT TRIỂN</a:t>
+            </a:r>
+          </a:p>
+        </p:txBody>
+      </p:sp>
+      <p:sp>
+        <p:nvSpPr>
+          <p:cNvPr id="5" name="TextBox 4"/>
+          <p:cNvSpPr txBox="1"/>
+          <p:nvPr/>
+        </p:nvSpPr>
+        <p:spPr>
+          <a:xfrm>
+            <a:off x="457200" y="1005840"/>
+            <a:ext cx="5669280" cy="5029200"/>
+          </a:xfrm>
+          <a:prstGeom prst="rect">
+            <a:avLst/>
+          </a:prstGeom>
+          <a:noFill/>
+        </p:spPr>
+        <p:txBody>
+          <a:bodyPr wrap="square">
+            <a:spAutoFit/>
+          </a:bodyPr>
+          <a:lstStyle/>
+          <a:p>
+            <a:pPr>
+              <a:spcBef>
+                <a:spcPts val="1400"/>
+              </a:spcBef>
+              <a:defRPr sz="1700" b="1">
+                <a:solidFill>
+                  <a:srgbClr val="2E86DE"/>
+                </a:solidFill>
+              </a:defRPr>
+            </a:pPr>
+            <a:r>
+              <a:t>Kết quả đạt được</a:t>
+            </a:r>
+          </a:p>
+          <a:p>
+            <a:pPr>
+              <a:spcBef>
+                <a:spcPts val="500"/>
+              </a:spcBef>
+              <a:defRPr sz="1500">
+                <a:solidFill>
+                  <a:srgbClr val="2C3E50"/>
+                </a:solidFill>
+              </a:defRPr>
+            </a:pPr>
+            <a:r>
+              <a:t>• Hệ thống TMĐT SmartVN hoàn chỉnh (7 microservices)</a:t>
+            </a:r>
+          </a:p>
+          <a:p>
+            <a:pPr>
+              <a:spcBef>
+                <a:spcPts val="500"/>
+              </a:spcBef>
+              <a:defRPr sz="1500">
+                <a:solidFill>
+                  <a:srgbClr val="2C3E50"/>
+                </a:solidFill>
+              </a:defRPr>
+            </a:pPr>
+            <a:r>
+              <a:t>• Ứng dụng Mobile Android native (MVVM) đầy đủ tính năng</a:t>
+            </a:r>
+          </a:p>
+          <a:p>
+            <a:pPr>
+              <a:spcBef>
+                <a:spcPts val="500"/>
+              </a:spcBef>
+              <a:defRPr sz="1500">
+                <a:solidFill>
+                  <a:srgbClr val="2C3E50"/>
+                </a:solidFill>
+              </a:defRPr>
+            </a:pPr>
+            <a:r>
+              <a:t>• Hiệu năng: Redis cache giảm latency 5.5x</a:t>
+            </a:r>
+          </a:p>
+          <a:p>
+            <a:pPr>
+              <a:spcBef>
+                <a:spcPts val="500"/>
+              </a:spcBef>
+              <a:defRPr sz="1500">
+                <a:solidFill>
+                  <a:srgbClr val="2C3E50"/>
+                </a:solidFill>
+              </a:defRPr>
+            </a:pPr>
+            <a:r>
+              <a:t>• Bảo mật: JWT + OAuth2 + Circuit Breaker</a:t>
+            </a:r>
+          </a:p>
+          <a:p>
+            <a:pPr>
+              <a:spcBef>
+                <a:spcPts val="500"/>
+              </a:spcBef>
+              <a:defRPr sz="1500">
+                <a:solidFill>
+                  <a:srgbClr val="2C3E50"/>
+                </a:solidFill>
+              </a:defRPr>
+            </a:pPr>
+            <a:r>
+              <a:t>• Docker Compose deployment</a:t>
+            </a:r>
+          </a:p>
+          <a:p>
+            <a:pPr>
+              <a:spcBef>
+                <a:spcPts val="500"/>
+              </a:spcBef>
+              <a:defRPr sz="1500">
+                <a:solidFill>
+                  <a:srgbClr val="2C3E50"/>
+                </a:solidFill>
+              </a:defRPr>
+            </a:pPr>
+          </a:p>
+          <a:p>
+            <a:pPr>
+              <a:spcBef>
+                <a:spcPts val="1400"/>
+              </a:spcBef>
+              <a:defRPr sz="1700" b="1">
+                <a:solidFill>
+                  <a:srgbClr val="2E86DE"/>
+                </a:solidFill>
+              </a:defRPr>
+            </a:pPr>
+            <a:r>
+              <a:t>Hướng phát triển</a:t>
+            </a:r>
+          </a:p>
+          <a:p>
+            <a:pPr>
+              <a:spcBef>
+                <a:spcPts val="500"/>
+              </a:spcBef>
+              <a:defRPr sz="1500">
+                <a:solidFill>
+                  <a:srgbClr val="2C3E50"/>
+                </a:solidFill>
+              </a:defRPr>
+            </a:pPr>
+            <a:r>
+              <a:t>• CI/CD pipeline (GitHub Actions)</a:t>
+            </a:r>
+          </a:p>
+          <a:p>
+            <a:pPr>
+              <a:spcBef>
+                <a:spcPts val="500"/>
+              </a:spcBef>
+              <a:defRPr sz="1500">
+                <a:solidFill>
+                  <a:srgbClr val="2C3E50"/>
+                </a:solidFill>
+              </a:defRPr>
+            </a:pPr>
+            <a:r>
+              <a:t>• Monitoring (Prometheus + Grafana)</a:t>
+            </a:r>
+          </a:p>
+          <a:p>
+            <a:pPr>
+              <a:spcBef>
+                <a:spcPts val="500"/>
+              </a:spcBef>
+              <a:defRPr sz="1500">
+                <a:solidFill>
+                  <a:srgbClr val="2C3E50"/>
+                </a:solidFill>
+              </a:defRPr>
+            </a:pPr>
+            <a:r>
+              <a:t>• Push notification (Firebase FCM)</a:t>
+            </a:r>
+          </a:p>
+          <a:p>
+            <a:pPr>
+              <a:spcBef>
+                <a:spcPts val="500"/>
+              </a:spcBef>
+              <a:defRPr sz="1500">
+                <a:solidFill>
+                  <a:srgbClr val="2C3E50"/>
+                </a:solidFill>
+              </a:defRPr>
+            </a:pPr>
+            <a:r>
+              <a:t>• Elasticsearch full-text search</a:t>
+            </a:r>
+          </a:p>
+          <a:p>
+            <a:pPr>
+              <a:spcBef>
+                <a:spcPts val="500"/>
+              </a:spcBef>
+              <a:defRPr sz="1500">
+                <a:solidFill>
+                  <a:srgbClr val="2C3E50"/>
+                </a:solidFill>
+              </a:defRPr>
+            </a:pPr>
+            <a:r>
+              <a:t>• iOS app (Flutter cross-platform)</a:t>
+            </a:r>
+          </a:p>
+        </p:txBody>
+      </p:sp>
+    </p:spTree>
+  </p:cSld>
+  <p:clrMapOvr>
+    <a:masterClrMapping/>
+  </p:clrMapOvr>
+</p:sld>
+</file>
+
+<file path=ppt/slides/slide21.xml><?xml version="1.0" encoding="utf-8"?>
 <p:sld xmlns:a="http://schemas.openxmlformats.org/drawingml/2006/main" xmlns:p="http://schemas.openxmlformats.org/presentationml/2006/main" xmlns:r="http://schemas.openxmlformats.org/officeDocument/2006/relationships">
   <p:cSld>
     <p:bg>
@@ -8105,21 +7583,6 @@
             </a:pPr>
             <a:r>
               <a:t>• Mobile Android native (Java, MVVM)</a:t>
-            </a:r>
-          </a:p>
-          <a:p>
-            <a:pPr>
-              <a:spcBef>
-                <a:spcPts val="500"/>
-              </a:spcBef>
-              <a:defRPr sz="1500">
-                <a:solidFill>
-                  <a:srgbClr val="2C3E50"/>
-                </a:solidFill>
-              </a:defRPr>
-            </a:pPr>
-            <a:r>
-              <a:t>• AI Recommendation (PhoBERT + ALS)</a:t>
             </a:r>
           </a:p>
         </p:txBody>
@@ -9261,18 +8724,7 @@
                   <a:txBody>
                     <a:bodyPr/>
                     <a:lstStyle/>
-                    <a:p>
-                      <a:pPr>
-                        <a:defRPr sz="1300">
-                          <a:solidFill>
-                            <a:srgbClr val="2C3E50"/>
-                          </a:solidFill>
-                        </a:defRPr>
-                      </a:pPr>
-                      <a:r>
-                        <a:t>Recommend Service</a:t>
-                      </a:r>
-                    </a:p>
+                    <a:p/>
                   </a:txBody>
                   <a:tcPr/>
                 </a:tc>
@@ -9280,18 +8732,7 @@
                   <a:txBody>
                     <a:bodyPr/>
                     <a:lstStyle/>
-                    <a:p>
-                      <a:pPr>
-                        <a:defRPr sz="1300">
-                          <a:solidFill>
-                            <a:srgbClr val="2C3E50"/>
-                          </a:solidFill>
-                        </a:defRPr>
-                      </a:pPr>
-                      <a:r>
-                        <a:t>8085</a:t>
-                      </a:r>
-                    </a:p>
+                    <a:p/>
                   </a:txBody>
                   <a:tcPr/>
                 </a:tc>
@@ -9299,18 +8740,7 @@
                   <a:txBody>
                     <a:bodyPr/>
                     <a:lstStyle/>
-                    <a:p>
-                      <a:pPr>
-                        <a:defRPr sz="1300">
-                          <a:solidFill>
-                            <a:srgbClr val="2C3E50"/>
-                          </a:solidFill>
-                        </a:defRPr>
-                      </a:pPr>
-                      <a:r>
-                        <a:t>AI Recommendation (PhoBERT+ALS)</a:t>
-                      </a:r>
-                    </a:p>
+                    <a:p/>
                   </a:txBody>
                   <a:tcPr/>
                 </a:tc>
@@ -9686,22 +9116,7 @@
               </a:defRPr>
             </a:pPr>
             <a:r>
-              <a:t>AI &amp; DevOps</a:t>
-            </a:r>
-          </a:p>
-          <a:p>
-            <a:pPr>
-              <a:spcBef>
-                <a:spcPts val="500"/>
-              </a:spcBef>
-              <a:defRPr sz="1500">
-                <a:solidFill>
-                  <a:srgbClr val="2C3E50"/>
-                </a:solidFill>
-              </a:defRPr>
-            </a:pPr>
-            <a:r>
-              <a:t>• PhoBERT + ALS Hybrid Recommendation</a:t>
+              <a:t>DevOps</a:t>
             </a:r>
           </a:p>
           <a:p>

</xml_diff>